<commit_message>
learn-notes 1.9.0: 문서 마지막 점검 고침
- 점검표 머리말: 1.9.0에서 기대가 바뀐 장면 목록에 장면 32를 넣음(장면 29가 다시 도전으로 끝나 '열린 채 두 번 이상'의 기대가 바뀜)
- CHANGELOG · README · 안내서 6장 · 견본: 1.9.0의 내 코드 문제를 '1.7처럼 그대로'가 아니라 1.8.0의 처음 두 단계(내 코드 칸)처럼 그대로라고 고침(1.7 프롬프트는 "그대로, 또는 조금 바꿔")
- README 데모 GIF 설명: 1.7 화면으로 만든 데모라 마지막 장면의 /learn 진단이 지금 판과 다르다고 밝힘
- README 담당자용 절 · 안내서 11장 · 소개 PPT 27장 발표 노트: oldWrites는 지워지지 않으므로 '오래 없음' 대신 '없음이거나 마지막 날짜가 오래전'으로 읽고, /reload-plugins 안내는 마지막 날짜가 최근일 때로 고침
- README · 안내서의 사용량 예(학습 보고 · /learn 기록 · 팀 학습 지도): 출력 토큰을 견본의 노트 · 퀴즈 출력 평균에 맞추고, haiku는 생각도 출력 토큰으로 센다는 설명을 붙임
- 안내서 PDF와 소개 PPT를 원본에서 다시 만듦(36쪽 그대로, 바뀐 것은 PPT 27장 발표 노트뿐)

Co-Authored-By: Claude Opus 5.5 <noreply@anthropic.com>
Claude-Session: https://claude.ai/code/session_019u8s2pttwUY2v21k1Zwy4Q
</commit_message>
<xml_diff>
--- a/docs/team/learn-notes-intro.pptx
+++ b/docs/team/learn-notes-intro.pptx
@@ -135,14 +135,14 @@
   <p:extLst>
     <p:ext uri="{521415D9-36F7-43E2-AB2F-B90AF26B5E84}">
       <p14:sectionLst xmlns:p14="http://schemas.microsoft.com/office/powerpoint/2010/main">
-        <p14:section name="시작" id="{b74e56fb-2507-bd92-3aaf-67aa7ca80acf}">
+        <p14:section name="시작" id="{7a02d2b5-9ccf-4187-ad98-f5ced7b1cd2b}">
           <p14:sldIdLst>
             <p14:sldId id="256"/>
             <p14:sldId id="257"/>
             <p14:sldId id="258"/>
           </p14:sldIdLst>
         </p14:section>
-        <p14:section name="모드(MOD)란?" id="{7010ae38-70aa-8c24-7657-806198a0f1e9}">
+        <p14:section name="모드(MOD)란?" id="{2b3a77f4-d5a8-afa9-749a-73d4be9ed597}">
           <p14:sldIdLst>
             <p14:sldId id="259"/>
             <p14:sldId id="260"/>
@@ -151,7 +151,7 @@
             <p14:sldId id="263"/>
           </p14:sldIdLst>
         </p14:section>
-        <p14:section name="learn-notes 기능" id="{8b4b6cb4-aef3-e4b8-bdcd-b15b73488a8e}">
+        <p14:section name="learn-notes 기능" id="{57ff812d-ddde-27cf-0d33-57992b4eb286}">
           <p14:sldIdLst>
             <p14:sldId id="264"/>
             <p14:sldId id="265"/>
@@ -167,7 +167,7 @@
             <p14:sldId id="275"/>
           </p14:sldIdLst>
         </p14:section>
-        <p14:section name="시작하기" id="{5e20c82a-384f-758d-c1e6-37f9607262e8}">
+        <p14:section name="시작하기" id="{f4bb578b-70a1-c4df-d111-87c84c6b8ec2}">
           <p14:sldIdLst>
             <p14:sldId id="276"/>
             <p14:sldId id="277"/>
@@ -179,7 +179,7 @@
             <p14:sldId id="283"/>
           </p14:sldIdLst>
         </p14:section>
-        <p14:section name="마무리" id="{5f58aa07-91e8-f9c1-d1e1-204e9646c259}">
+        <p14:section name="마무리" id="{0e8e0a04-5b1a-2fb4-2fa4-884fc14291d2}">
           <p14:sldIdLst>
             <p14:sldId id="284"/>
           </p14:sldIdLst>
@@ -2260,7 +2260,7 @@
           <a:p>
             <a:r>
               <a:rPr lang="en-US" dirty="0"/>
-              <a:t>회사에 넓게 깔 때 담당자가 알아 두실 것입니다. 첫째, /learn 진단입니다. 노트가 안 생기거나 패널이 이상하면 대화창에 /learn 진단을 치게 해 주세요. 모델을 부르지 않고 버전, 다른 창의 버전, 화면, 설정(관리자가 잠근 값 표시), 오늘 노트·호출·실패 수, 저장소 크기, 오답 노트 개수, 최근 7일의 문제를 원인별로 정리해 클립보드에 복사하고 대화창에도 적습니다. 오답 노트 줄은 헷갈린 점이 몇 개인지, 그중 열린 것과 바로잡은 것, 유형 기타와 문장 없음, 그리고 "열린 채 두 번 이상", 곧 바로잡지 못한 채 연달아 두 번 이상 헷갈린 것(되묻기 뒤에 맞힌 것 포함)이 몇 개인지 개수만 셉니다. 코드, 요청, 파일 이름, 경로, 개념 이름, 헷갈린 점 문장은 들어 있지 않으니 팀 채널에 그대로 붙여도 됩니다. 복사할 수 없는 화면에서는 대화창에만 적습니다. 왼쪽 글은 예시 화면에서 뽑은 것으로, 다른 터미널에 아직 1.8.0 창이 열려 있던 기기의 진단입니다. 그래서 "다른 창" 줄에 1.8.0이 보입니다. 둘째, 버전이 섞인 팀입니다. 1.9.0부터는 진단의 저장소 줄 끝에 "옛 판 창의 개념 모음 쓰기"가 붙습니다. 1.9.0은 개념 모음을 쓸 때 자기가 썼다는 표식을 함께 남기고, 그 뒤 1.9.0보다 옛 판 창이 개념 모음을 다시 쓰면, 1.9.0 창이 그 개념 모음을 읽을 때 알아채서 셉니다. "없음 (10-03부터)"는 이 기기에서 1.9.0이 처음 개념 모음을 쓴 날부터 1.9.0 창이 옛 판 창의 쓰기를 보지 못했다는 뜻입니다. "마지막 10-05 01:30 (10-03부터 1번)"은 옛 판 창의 마지막 쓰기를 1.9.0 창이 처음 본 때와 그 횟수입니다. 옛 창이 쓴 시각이 아니고, 같은 쓰기를 다시 읽어도 바뀌지 않습니다. 저장소를 읽지 못하면 "읽지 못함"이라고 나옵니다. 이 기록에는 개념 이름이 없고, 같은 쓰기를 두 번 세지 않으려는 짧은 지문만 있습니다. 버전이 섞여 있어도 학습 기록은 이어집니다. 1.9.0은 옛 창이 읽는 안다 표시와 복습 단계의 사본을 계속 씁니다. 그래서 1.5부터 1.8까지의 창이 같은 기록을 함께 써도, 1.8.0 이하로 되돌려도 그대로 동작합니다. 1.9.0이 마지막으로 쓴 개념 모음에서는 그 사본을 읽지 않을 뿐입니다. 개념 모음을 쓸 때마다 저장소 읽기가 한 번 늘지만, 모델 호출은 아닙니다. 팀 전체의 진단에서 이 줄이 계속 "없음"이면, 뒷날 판이 사본 쓰기를 멈출 수 있는지 가늠하는 자료가 됩니다. 회사에 깐 뒤 진단을 받으시면 이 줄도 함께 봐 주세요. 업데이트한 뒤 다른 창이 더 새 버전을 쓰고 있으면, 옛 창에 흐린 줄과 토스트가 한 번 뜨고 /reload-plugins를 안내합니다. 저장소가 더 새 구조로 쓰였으면 옛 창은 다시 불러올 때까지 개념 모음과 복습 단계를 고치지 않고, 노트와 일지는 그대로 씁니다. 이 알림은 1.7.0 창부터 보입니다. 새 구조를 쓰는 판을 깔았다가 1.7로 되돌린 경우처럼 다시 불러와도 이 상태가 남으면, 알림 끝에 "다시 불러와도 계속되면 /learn 진단을 담당자에게 보내 주세요"가 붙고, 진단의 "다른 창" 줄에 저장소가 새 구조라는 것이 나옵니다. 창을 여러 개 열어 같은 퀴즈를 풀어도 첫 오답, 힌트, 채점이 사라지거나 두 번 세지지 않습니다. 다른 창에서 먼저 답한 문제에는 "이 문제는 그사이 다른 창에서 먼저 답했습니다. 한 번 더 적어 보세요."가 나옵니다. 실패 알림도 원인을 말합니다. 디스크가 가득 찼는지, 폴더에 쓸 권한이 없는지, 로그인이 필요한지, 요청 한도에 걸렸는지를 나눠 알려 줍니다. Claude Code의 저장소가 크기 한도로 쓰기를 거절한 것도 알아듣고 "저장소가 4MB를 넘었습니다"로 알려 주며, 진단에는 "저장소 4MB 넘음"으로 나옵니다. 셋째, 노트가 끊기지 않게 했습니다. 자동 노트가 서버 붐빔(529), 서버 오류, 연결 끊김, 시간 초과로 실패하면 노란 줄로 알리고 30초 뒤 한 번 더 씁니다. 두 번째도 실패하면 빨간 줄로 이유와 할 일을 알려 줍니다. 요청 한도에 걸린 것은 메인 세션과 나눠 쓰는 한도라 저절로 다시 쓰지 않습니다. /reload-plugins나 /config 변경 직후에 쓰다 멈춘 노트는 10분 안이면 저절로 이어 씁니다. w로 다시 쓰던 노트가 그렇게 끊기면 원래 노트로 돌아오고, "다시 불러오는 사이 노트 다시 쓰기가 끊겼습니다 · 원래 노트는 그대로입니다 · w로 다시 쓰기" 토스트가 한 번 뜹니다. 30초 뒤 다시 쓰기를 기다리는 동안 /learn 비우기를 확인하면, 그 노트는 다시 쓰지 않고 실패한 노트로 일지에 남깁니다. 구독 계정에서 5시간 사용 한도의 90%, 7일 한도의 95%를 넘으면 자동 노트를 미루고, w를 누르면 바로 씁니다. 이 문턱은 설정이 아니라 고정값입니다. 다시 쓴 호출은 모델 호출 수에는 들어가지만 하루 자동 노트 한도에는 세지 않습니다.</a:t>
+              <a:t>회사에 넓게 깔 때 담당자가 알아 두실 것입니다. 첫째, /learn 진단입니다. 노트가 안 생기거나 패널이 이상하면 대화창에 /learn 진단을 치게 해 주세요. 모델을 부르지 않고 버전, 다른 창의 버전, 화면, 설정(관리자가 잠근 값 표시), 오늘 노트·호출·실패 수, 저장소 크기, 오답 노트 개수, 최근 7일의 문제를 원인별로 정리해 클립보드에 복사하고 대화창에도 적습니다. 오답 노트 줄은 헷갈린 점이 몇 개인지, 그중 열린 것과 바로잡은 것, 유형 기타와 문장 없음, 그리고 "열린 채 두 번 이상", 곧 바로잡지 못한 채 연달아 두 번 이상 헷갈린 것(되묻기 뒤에 맞힌 것 포함)이 몇 개인지 개수만 셉니다. 코드, 요청, 파일 이름, 경로, 개념 이름, 헷갈린 점 문장은 들어 있지 않으니 팀 채널에 그대로 붙여도 됩니다. 복사할 수 없는 화면에서는 대화창에만 적습니다. 왼쪽 글은 예시 화면에서 뽑은 것으로, 다른 터미널에 아직 1.8.0 창이 열려 있던 기기의 진단입니다. 그래서 "다른 창" 줄에 1.8.0이 보입니다. 둘째, 버전이 섞인 팀입니다. 1.9.0부터는 진단의 저장소 줄 끝에 "옛 판 창의 개념 모음 쓰기"가 붙습니다. 1.9.0은 개념 모음을 쓸 때 자기가 썼다는 표식을 함께 남기고, 그 뒤 1.9.0보다 옛 판 창이 개념 모음을 다시 쓰면, 1.9.0 창이 그 개념 모음을 읽을 때 알아채서 셉니다. "없음 (10-03부터)"는 이 기기에서 1.9.0이 처음 개념 모음을 쓴 날부터 1.9.0 창이 옛 판 창의 쓰기를 보지 못했다는 뜻입니다. "마지막 10-05 01:30 (10-03부터 1번)"은 옛 판 창의 마지막 쓰기를 1.9.0 창이 처음 본 때와 그 횟수입니다. 옛 창이 쓴 시각이 아니고, 같은 쓰기를 다시 읽어도 바뀌지 않습니다. 저장소를 읽지 못하면 "읽지 못함"이라고 나옵니다. 이 기록에는 개념 이름이 없고, 같은 쓰기를 두 번 세지 않으려는 짧은 지문만 있습니다. 버전이 섞여 있어도 학습 기록은 이어집니다. 1.9.0은 옛 창이 읽는 안다 표시와 복습 단계의 사본을 계속 씁니다. 그래서 1.5부터 1.8까지의 창이 같은 기록을 함께 써도, 1.8.0 이하로 되돌려도 그대로 동작합니다. 1.9.0이 마지막으로 쓴 개념 모음에서는 그 사본을 읽지 않을 뿐입니다. 개념 모음을 쓸 때마다 저장소 읽기가 한 번 늘지만, 모델 호출은 아닙니다. 팀 전체의 진단에서 이 부분이 계속 "없음"이거나 "마지막" 날짜가 오래전이면, 뒷날 판이 사본 쓰기를 멈출 수 있는지 가늠하는 자료가 됩니다. 한 번 센 기록은 지워지지 않아서, 업데이트하는 동안 옛 판 창이 한 번만 써도 그 기기는 계속 "마지막"으로 보입니다. 그러니 날짜를 봐 주세요. 회사에 깐 뒤 진단을 받으시면 이 줄도 함께 봐 주세요. 업데이트한 뒤 다른 창이 더 새 버전을 쓰고 있으면, 옛 창에 흐린 줄과 토스트가 한 번 뜨고 /reload-plugins를 안내합니다. 저장소가 더 새 구조로 쓰였으면 옛 창은 다시 불러올 때까지 개념 모음과 복습 단계를 고치지 않고, 노트와 일지는 그대로 씁니다. 이 알림은 1.7.0 창부터 보입니다. 새 구조를 쓰는 판을 깔았다가 1.7로 되돌린 경우처럼 다시 불러와도 이 상태가 남으면, 알림 끝에 "다시 불러와도 계속되면 /learn 진단을 담당자에게 보내 주세요"가 붙고, 진단의 "다른 창" 줄에 저장소가 새 구조라는 것이 나옵니다. 창을 여러 개 열어 같은 퀴즈를 풀어도 첫 오답, 힌트, 채점이 사라지거나 두 번 세지지 않습니다. 다른 창에서 먼저 답한 문제에는 "이 문제는 그사이 다른 창에서 먼저 답했습니다. 한 번 더 적어 보세요."가 나옵니다. 실패 알림도 원인을 말합니다. 디스크가 가득 찼는지, 폴더에 쓸 권한이 없는지, 로그인이 필요한지, 요청 한도에 걸렸는지를 나눠 알려 줍니다. Claude Code의 저장소가 크기 한도로 쓰기를 거절한 것도 알아듣고 "저장소가 4MB를 넘었습니다"로 알려 주며, 진단에는 "저장소 4MB 넘음"으로 나옵니다. 셋째, 노트가 끊기지 않게 했습니다. 자동 노트가 서버 붐빔(529), 서버 오류, 연결 끊김, 시간 초과로 실패하면 노란 줄로 알리고 30초 뒤 한 번 더 씁니다. 두 번째도 실패하면 빨간 줄로 이유와 할 일을 알려 줍니다. 요청 한도에 걸린 것은 메인 세션과 나눠 쓰는 한도라 저절로 다시 쓰지 않습니다. /reload-plugins나 /config 변경 직후에 쓰다 멈춘 노트는 10분 안이면 저절로 이어 씁니다. w로 다시 쓰던 노트가 그렇게 끊기면 원래 노트로 돌아오고, "다시 불러오는 사이 노트 다시 쓰기가 끊겼습니다 · 원래 노트는 그대로입니다 · w로 다시 쓰기" 토스트가 한 번 뜹니다. 30초 뒤 다시 쓰기를 기다리는 동안 /learn 비우기를 확인하면, 그 노트는 다시 쓰지 않고 실패한 노트로 일지에 남깁니다. 구독 계정에서 5시간 사용 한도의 90%, 7일 한도의 95%를 넘으면 자동 노트를 미루고, w를 누르면 바로 씁니다. 이 문턱은 설정이 아니라 고정값입니다. 다시 쓴 호출은 모델 호출 수에는 들어가지만 하루 자동 노트 한도에는 세지 않습니다.</a:t>
             </a:r>
             <a:endParaRPr lang="en-US" dirty="0"/>
           </a:p>

</xml_diff>